<commit_message>
feat: execute two-party recovery on the QBFT ledger
</commit_message>
<xml_diff>
--- a/submission/CallSign_기획제안서.pptx
+++ b/submission/CallSign_기획제안서.pptx
@@ -3318,7 +3318,7 @@
                   <a:srgbClr val="DCE9ED"/>
                 </a:solidFill>
               </a:rPr>
-              <a:t>• Vitest 프로토콜·위험 분석 19/19</a:t>
+              <a:t>• Vitest 프로토콜·위험 분석 20/20</a:t>
             </a:r>
             <a:endParaRPr lang="en-US" sz="1430" dirty="0"/>
           </a:p>
@@ -3332,7 +3332,7 @@
                   <a:srgbClr val="DCE9ED"/>
                 </a:solidFill>
               </a:rPr>
-              <a:t>• PostgreSQL/API 통합 9/9</a:t>
+              <a:t>• PostgreSQL/API 통합 10/10</a:t>
             </a:r>
             <a:endParaRPr lang="en-US" sz="1430" dirty="0"/>
           </a:p>
@@ -3346,7 +3346,7 @@
                   <a:srgbClr val="DCE9ED"/>
                 </a:solidFill>
               </a:rPr>
-              <a:t>• Playwright 10/10</a:t>
+              <a:t>• Playwright 11/11</a:t>
             </a:r>
             <a:endParaRPr lang="en-US" sz="1430" dirty="0"/>
           </a:p>
@@ -3388,7 +3388,7 @@
                   <a:srgbClr val="DCE9ED"/>
                 </a:solidFill>
               </a:rPr>
-              <a:t>• 실제 WebRTC DTLS·audio·revoke 캡처</a:t>
+              <a:t>• WebRTC·revoke·2-of-3 복구 LIVE 캡처</a:t>
             </a:r>
             <a:endParaRPr lang="en-US" sz="1430" dirty="0"/>
           </a:p>
@@ -12228,7 +12228,7 @@
                   <a:srgbClr val="53636F"/>
                 </a:solidFill>
               </a:rPr>
-              <a:t>Besu 4노드 · witness 4개 · 계약 · 승인/소비 · 두 브라우저 WebRTC · 실제 취소 · 공식 업무 권한 · 규칙 기반 위험 안내</a:t>
+              <a:t>Besu 4노드 · witness 4개 · 승인/소비 · 두 브라우저 WebRTC · 실제 취소·2-of-3 복구 · 공식 업무 권한 · 규칙 위험 안내</a:t>
             </a:r>
             <a:endParaRPr lang="en-US" sz="1400" dirty="0"/>
           </a:p>

</xml_diff>